<commit_message>
docs: minor adjustments to operational documentation and labels
</commit_message>
<xml_diff>
--- a/apresentacao/engenharia-plataforma.pptx
+++ b/apresentacao/engenharia-plataforma.pptx
@@ -2334,7 +2334,40 @@
                 <a:ea typeface="Arial" pitchFamily="34" charset="-122"/>
                 <a:cs typeface="Arial" pitchFamily="34" charset="-120"/>
               </a:rPr>
-              <a:t>O Controlador Sênior de Deploy</a:t>
+              <a:t>O </a:t>
+            </a:r>
+            <a:r>
+              <a:rPr lang="en-US" sz="3200" b="1" dirty="0" err="1">
+                <a:solidFill>
+                  <a:srgbClr val="FFFFFF"/>
+                </a:solidFill>
+                <a:latin typeface="Arial" pitchFamily="34" charset="0"/>
+                <a:ea typeface="Arial" pitchFamily="34" charset="-122"/>
+                <a:cs typeface="Arial" pitchFamily="34" charset="-120"/>
+              </a:rPr>
+              <a:t>Controlador</a:t>
+            </a:r>
+            <a:r>
+              <a:rPr lang="en-US" sz="3200" b="1">
+                <a:solidFill>
+                  <a:srgbClr val="FFFFFF"/>
+                </a:solidFill>
+                <a:latin typeface="Arial" pitchFamily="34" charset="0"/>
+                <a:ea typeface="Arial" pitchFamily="34" charset="-122"/>
+                <a:cs typeface="Arial" pitchFamily="34" charset="-120"/>
+              </a:rPr>
+              <a:t> de </a:t>
+            </a:r>
+            <a:r>
+              <a:rPr lang="en-US" sz="3200" b="1" dirty="0">
+                <a:solidFill>
+                  <a:srgbClr val="FFFFFF"/>
+                </a:solidFill>
+                <a:latin typeface="Arial" pitchFamily="34" charset="0"/>
+                <a:ea typeface="Arial" pitchFamily="34" charset="-122"/>
+                <a:cs typeface="Arial" pitchFamily="34" charset="-120"/>
+              </a:rPr>
+              <a:t>Deploy</a:t>
             </a:r>
             <a:endParaRPr lang="en-US" sz="3200" dirty="0"/>
           </a:p>

</xml_diff>